<commit_message>
Update project slides with names removed
Co-Authored-By: Claude Sonnet 5.5 <noreply@anthropic.com>
Claude-Session: https://claude.ai/code/session_01GUDNJjFV8jsFzVg5X9uZHY
</commit_message>
<xml_diff>
--- a/docs/uart_final.pptx
+++ b/docs/uart_final.pptx
@@ -2283,7 +2283,7 @@
           </a:prstGeom>
           <a:extLst>
             <a:ext uri="{C572A759-6A51-4108-AA02-DFA0A04FC94B}">
-              <ma14:wrappingTextBoxFlag xmlns:ma14="http://schemas.microsoft.com/office/mac/drawingml/2011/main" xmlns="" val="0"/>
+              <ma14:wrappingTextBoxFlag xmlns="" xmlns:ma14="http://schemas.microsoft.com/office/mac/drawingml/2011/main" val="0"/>
             </a:ext>
           </a:extLst>
         </p:spPr>
@@ -2441,7 +2441,7 @@
           </a:prstGeom>
           <a:extLst>
             <a:ext uri="{C572A759-6A51-4108-AA02-DFA0A04FC94B}">
-              <ma14:wrappingTextBoxFlag xmlns:ma14="http://schemas.microsoft.com/office/mac/drawingml/2011/main" xmlns="" val="0"/>
+              <ma14:wrappingTextBoxFlag xmlns="" xmlns:ma14="http://schemas.microsoft.com/office/mac/drawingml/2011/main" val="0"/>
             </a:ext>
           </a:extLst>
         </p:spPr>
@@ -2549,7 +2549,7 @@
           </a:prstGeom>
           <a:extLst>
             <a:ext uri="{C572A759-6A51-4108-AA02-DFA0A04FC94B}">
-              <ma14:wrappingTextBoxFlag xmlns:ma14="http://schemas.microsoft.com/office/mac/drawingml/2011/main" xmlns="" val="0"/>
+              <ma14:wrappingTextBoxFlag xmlns="" xmlns:ma14="http://schemas.microsoft.com/office/mac/drawingml/2011/main" val="0"/>
             </a:ext>
           </a:extLst>
         </p:spPr>
@@ -2881,22 +2881,6 @@
               </a:spcAft>
               <a:buNone/>
             </a:pPr>
-            <a:r>
-              <a:rPr lang="en-US" dirty="0">
-                <a:solidFill>
-                  <a:schemeClr val="accent3"/>
-                </a:solidFill>
-              </a:rPr>
-              <a:t>P</a:t>
-            </a:r>
-            <a:r>
-              <a:rPr lang="en-US" sz="1800" dirty="0">
-                <a:solidFill>
-                  <a:schemeClr val="accent3"/>
-                </a:solidFill>
-              </a:rPr>
-              <a:t>roject review</a:t>
-            </a:r>
             <a:endParaRPr lang="en-US" sz="1800" dirty="0"/>
           </a:p>
         </p:txBody>
@@ -2909,7 +2893,7 @@
         </p:nvSpPr>
         <p:spPr>
           <a:xfrm>
-            <a:off x="731520" y="1234440"/>
+            <a:off x="630936" y="2058963"/>
             <a:ext cx="9601200" cy="1920240"/>
           </a:xfrm>
           <a:prstGeom prst="rect">
@@ -2951,7 +2935,7 @@
         </p:nvSpPr>
         <p:spPr>
           <a:xfrm>
-            <a:off x="731520" y="3156243"/>
+            <a:off x="731520" y="3830339"/>
             <a:ext cx="8686800" cy="822960"/>
           </a:xfrm>
           <a:prstGeom prst="rect">
@@ -2990,7 +2974,7 @@
         </p:nvSpPr>
         <p:spPr>
           <a:xfrm>
-            <a:off x="731520" y="4800600"/>
+            <a:off x="731520" y="6007608"/>
             <a:ext cx="10725912" cy="0"/>
           </a:xfrm>
           <a:prstGeom prst="line">
@@ -3008,355 +2992,7 @@
           <a:bodyPr/>
           <a:lstStyle/>
           <a:p>
-            <a:endParaRPr lang="en-IN"/>
-          </a:p>
-        </p:txBody>
-      </p:sp>
-      <p:sp>
-        <p:nvSpPr>
-          <p:cNvPr id="7" name="Text 4"/>
-          <p:cNvSpPr txBox="1"/>
-          <p:nvPr/>
-        </p:nvSpPr>
-        <p:spPr>
-          <a:xfrm>
-            <a:off x="731520" y="4983480"/>
-            <a:ext cx="2560320" cy="274320"/>
-          </a:xfrm>
-          <a:prstGeom prst="rect">
-            <a:avLst/>
-          </a:prstGeom>
-          <a:noFill/>
-          <a:ln/>
-        </p:spPr>
-        <p:txBody>
-          <a:bodyPr wrap="square" lIns="0" tIns="0" rIns="0" bIns="0" rtlCol="0" anchor="t"/>
-          <a:lstStyle/>
-          <a:p>
-            <a:pPr marL="0" indent="0">
-              <a:spcAft>
-                <a:spcPts val="400"/>
-              </a:spcAft>
-              <a:buNone/>
-            </a:pPr>
-            <a:r>
-              <a:rPr lang="en-US" sz="1200" dirty="0">
-                <a:solidFill>
-                  <a:schemeClr val="accent6"/>
-                </a:solidFill>
-              </a:rPr>
-              <a:t>Presented by</a:t>
-            </a:r>
-            <a:endParaRPr lang="en-US" sz="1200" dirty="0"/>
-          </a:p>
-        </p:txBody>
-      </p:sp>
-      <p:sp>
-        <p:nvSpPr>
-          <p:cNvPr id="8" name="Text 5"/>
-          <p:cNvSpPr txBox="1"/>
-          <p:nvPr/>
-        </p:nvSpPr>
-        <p:spPr>
-          <a:xfrm>
-            <a:off x="646726" y="5209344"/>
-            <a:ext cx="4392245" cy="1527518"/>
-          </a:xfrm>
-          <a:prstGeom prst="rect">
-            <a:avLst/>
-          </a:prstGeom>
-          <a:noFill/>
-          <a:ln/>
-        </p:spPr>
-        <p:txBody>
-          <a:bodyPr wrap="square" lIns="0" tIns="0" rIns="0" bIns="0" rtlCol="0" anchor="t"/>
-          <a:lstStyle/>
-          <a:p>
-            <a:pPr marL="0" indent="0">
-              <a:spcAft>
-                <a:spcPts val="400"/>
-              </a:spcAft>
-              <a:buNone/>
-            </a:pPr>
-            <a:r>
-              <a:rPr lang="en-US" sz="1700" b="1" dirty="0">
-                <a:solidFill>
-                  <a:schemeClr val="bg2"/>
-                </a:solidFill>
-              </a:rPr>
-              <a:t>K Sai Akhil                         Am.En.P2VLD26006       </a:t>
-            </a:r>
-          </a:p>
-          <a:p>
-            <a:pPr>
-              <a:spcAft>
-                <a:spcPts val="400"/>
-              </a:spcAft>
-            </a:pPr>
-            <a:r>
-              <a:rPr lang="en-US" sz="1700" b="1" dirty="0" err="1">
-                <a:solidFill>
-                  <a:schemeClr val="bg2"/>
-                </a:solidFill>
-              </a:rPr>
-              <a:t>Indiresh</a:t>
-            </a:r>
-            <a:r>
-              <a:rPr lang="en-US" sz="1700" b="1" dirty="0">
-                <a:solidFill>
-                  <a:schemeClr val="bg2"/>
-                </a:solidFill>
-              </a:rPr>
-              <a:t>                             Am.En.P2VLD26012</a:t>
-            </a:r>
-          </a:p>
-          <a:p>
-            <a:pPr>
-              <a:spcAft>
-                <a:spcPts val="400"/>
-              </a:spcAft>
-            </a:pPr>
-            <a:r>
-              <a:rPr lang="en-US" sz="1700" b="1" dirty="0">
-                <a:solidFill>
-                  <a:schemeClr val="bg2"/>
-                </a:solidFill>
-              </a:rPr>
-              <a:t>Hemanth B R                    Am.En.P2VLD26015 </a:t>
-            </a:r>
-          </a:p>
-          <a:p>
-            <a:pPr>
-              <a:spcAft>
-                <a:spcPts val="400"/>
-              </a:spcAft>
-            </a:pPr>
-            <a:r>
-              <a:rPr lang="en-US" sz="1700" b="1" dirty="0">
-                <a:solidFill>
-                  <a:schemeClr val="bg2"/>
-                </a:solidFill>
-              </a:rPr>
-              <a:t>Hanuman K                      Am.En.P2VLD26027 </a:t>
-            </a:r>
-          </a:p>
-          <a:p>
-            <a:pPr>
-              <a:spcAft>
-                <a:spcPts val="400"/>
-              </a:spcAft>
-            </a:pPr>
-            <a:r>
-              <a:rPr lang="en-US" sz="1700" b="1" dirty="0">
-                <a:solidFill>
-                  <a:schemeClr val="bg2"/>
-                </a:solidFill>
-              </a:rPr>
-              <a:t>B Vallabha                        Am.En.P2VLD26029 </a:t>
-            </a:r>
-          </a:p>
-          <a:p>
-            <a:pPr marL="0" indent="0">
-              <a:spcAft>
-                <a:spcPts val="400"/>
-              </a:spcAft>
-              <a:buNone/>
-            </a:pPr>
-            <a:endParaRPr lang="en-US" sz="1700" b="1" dirty="0">
-              <a:solidFill>
-                <a:schemeClr val="bg2"/>
-              </a:solidFill>
-            </a:endParaRPr>
-          </a:p>
-          <a:p>
-            <a:pPr marL="0" indent="0">
-              <a:spcAft>
-                <a:spcPts val="400"/>
-              </a:spcAft>
-              <a:buNone/>
-            </a:pPr>
-            <a:r>
-              <a:rPr lang="en-US" sz="1700" b="1" dirty="0">
-                <a:solidFill>
-                  <a:schemeClr val="bg2"/>
-                </a:solidFill>
-              </a:rPr>
-              <a:t> </a:t>
-            </a:r>
-          </a:p>
-          <a:p>
-            <a:pPr marL="0" indent="0">
-              <a:spcAft>
-                <a:spcPts val="400"/>
-              </a:spcAft>
-              <a:buNone/>
-            </a:pPr>
-            <a:endParaRPr lang="en-US" sz="1700" dirty="0"/>
-          </a:p>
-        </p:txBody>
-      </p:sp>
-      <p:sp>
-        <p:nvSpPr>
-          <p:cNvPr id="9" name="Text 6"/>
-          <p:cNvSpPr txBox="1"/>
-          <p:nvPr/>
-        </p:nvSpPr>
-        <p:spPr>
-          <a:xfrm>
-            <a:off x="3022992" y="4960620"/>
-            <a:ext cx="2560320" cy="320040"/>
-          </a:xfrm>
-          <a:prstGeom prst="rect">
-            <a:avLst/>
-          </a:prstGeom>
-          <a:noFill/>
-          <a:ln/>
-        </p:spPr>
-        <p:txBody>
-          <a:bodyPr wrap="square" lIns="0" tIns="0" rIns="0" bIns="0" rtlCol="0" anchor="t"/>
-          <a:lstStyle/>
-          <a:p>
-            <a:pPr marL="0" indent="0">
-              <a:spcAft>
-                <a:spcPts val="400"/>
-              </a:spcAft>
-              <a:buNone/>
-            </a:pPr>
-            <a:r>
-              <a:rPr lang="en-US" sz="1400" dirty="0">
-                <a:solidFill>
-                  <a:schemeClr val="accent6"/>
-                </a:solidFill>
-              </a:rPr>
-              <a:t>Register number</a:t>
-            </a:r>
-            <a:endParaRPr lang="en-US" sz="1400" dirty="0"/>
-          </a:p>
-        </p:txBody>
-      </p:sp>
-      <p:sp>
-        <p:nvSpPr>
-          <p:cNvPr id="10" name="Text 7"/>
-          <p:cNvSpPr txBox="1"/>
-          <p:nvPr/>
-        </p:nvSpPr>
-        <p:spPr>
-          <a:xfrm>
-            <a:off x="6339842" y="4867812"/>
-            <a:ext cx="2560320" cy="274320"/>
-          </a:xfrm>
-          <a:prstGeom prst="rect">
-            <a:avLst/>
-          </a:prstGeom>
-          <a:noFill/>
-          <a:ln/>
-        </p:spPr>
-        <p:txBody>
-          <a:bodyPr wrap="square" lIns="0" tIns="0" rIns="0" bIns="0" rtlCol="0" anchor="t"/>
-          <a:lstStyle/>
-          <a:p>
-            <a:pPr marL="0" indent="0">
-              <a:spcAft>
-                <a:spcPts val="400"/>
-              </a:spcAft>
-              <a:buNone/>
-            </a:pPr>
-            <a:r>
-              <a:rPr lang="en-US" sz="1200" dirty="0">
-                <a:solidFill>
-                  <a:schemeClr val="accent6"/>
-                </a:solidFill>
-              </a:rPr>
-              <a:t>Guided by</a:t>
-            </a:r>
-            <a:endParaRPr lang="en-US" sz="1200" dirty="0"/>
-          </a:p>
-        </p:txBody>
-      </p:sp>
-      <p:sp>
-        <p:nvSpPr>
-          <p:cNvPr id="11" name="Text 8"/>
-          <p:cNvSpPr txBox="1"/>
-          <p:nvPr/>
-        </p:nvSpPr>
-        <p:spPr>
-          <a:xfrm>
-            <a:off x="6220656" y="5209343"/>
-            <a:ext cx="2560320" cy="365760"/>
-          </a:xfrm>
-          <a:prstGeom prst="rect">
-            <a:avLst/>
-          </a:prstGeom>
-          <a:noFill/>
-          <a:ln/>
-        </p:spPr>
-        <p:txBody>
-          <a:bodyPr wrap="square" lIns="0" tIns="0" rIns="0" bIns="0" rtlCol="0" anchor="t"/>
-          <a:lstStyle/>
-          <a:p>
-            <a:pPr marL="0" indent="0">
-              <a:spcAft>
-                <a:spcPts val="400"/>
-              </a:spcAft>
-              <a:buNone/>
-            </a:pPr>
-            <a:r>
-              <a:rPr lang="en-US" sz="1700" b="1" dirty="0">
-                <a:solidFill>
-                  <a:schemeClr val="bg2"/>
-                </a:solidFill>
-              </a:rPr>
-              <a:t>Jaya Krishnan</a:t>
-            </a:r>
-            <a:endParaRPr lang="en-US" sz="1700" dirty="0"/>
-          </a:p>
-        </p:txBody>
-      </p:sp>
-      <p:sp>
-        <p:nvSpPr>
-          <p:cNvPr id="12" name="Text 9"/>
-          <p:cNvSpPr txBox="1"/>
-          <p:nvPr/>
-        </p:nvSpPr>
-        <p:spPr>
-          <a:xfrm>
-            <a:off x="5336932" y="5486400"/>
-            <a:ext cx="3444044" cy="898768"/>
-          </a:xfrm>
-          <a:prstGeom prst="rect">
-            <a:avLst/>
-          </a:prstGeom>
-          <a:noFill/>
-          <a:ln/>
-        </p:spPr>
-        <p:txBody>
-          <a:bodyPr wrap="square" lIns="0" tIns="0" rIns="0" bIns="0" rtlCol="0" anchor="t"/>
-          <a:lstStyle>
-            <a:lvl1pPr>
-              <a:spcAft>
-                <a:spcPts val="400"/>
-              </a:spcAft>
-              <a:defRPr sz="1400">
-                <a:solidFill>
-                  <a:schemeClr val="accent6"/>
-                </a:solidFill>
-              </a:defRPr>
-            </a:lvl1pPr>
-          </a:lstStyle>
-          <a:p>
-            <a:r>
-              <a:rPr lang="en-US" dirty="0"/>
-              <a:t>                           Professor</a:t>
-            </a:r>
-          </a:p>
-          <a:p>
-            <a:r>
-              <a:rPr lang="en-IN" dirty="0"/>
-              <a:t>          Amrita Vishwa Vidyapeetham</a:t>
-            </a:r>
-          </a:p>
-          <a:p>
-            <a:endParaRPr lang="en-US" dirty="0"/>
+            <a:endParaRPr lang="en-IN" dirty="0"/>
           </a:p>
         </p:txBody>
       </p:sp>
@@ -3830,7 +3466,7 @@
           </a:prstGeom>
           <a:extLst>
             <a:ext uri="{C572A759-6A51-4108-AA02-DFA0A04FC94B}">
-              <ma14:wrappingTextBoxFlag xmlns:ma14="http://schemas.microsoft.com/office/mac/drawingml/2011/main" xmlns="" val="0"/>
+              <ma14:wrappingTextBoxFlag xmlns="" xmlns:ma14="http://schemas.microsoft.com/office/mac/drawingml/2011/main" val="0"/>
             </a:ext>
           </a:extLst>
         </p:spPr>
@@ -4178,7 +3814,7 @@
           </a:prstGeom>
           <a:extLst>
             <a:ext uri="{C572A759-6A51-4108-AA02-DFA0A04FC94B}">
-              <ma14:wrappingTextBoxFlag xmlns:ma14="http://schemas.microsoft.com/office/mac/drawingml/2011/main" xmlns="" val="0"/>
+              <ma14:wrappingTextBoxFlag xmlns="" xmlns:ma14="http://schemas.microsoft.com/office/mac/drawingml/2011/main" val="0"/>
             </a:ext>
           </a:extLst>
         </p:spPr>
@@ -4699,7 +4335,7 @@
           </a:prstGeom>
           <a:extLst>
             <a:ext uri="{C572A759-6A51-4108-AA02-DFA0A04FC94B}">
-              <ma14:wrappingTextBoxFlag xmlns:ma14="http://schemas.microsoft.com/office/mac/drawingml/2011/main" xmlns="" val="0"/>
+              <ma14:wrappingTextBoxFlag xmlns="" xmlns:ma14="http://schemas.microsoft.com/office/mac/drawingml/2011/main" val="0"/>
             </a:ext>
           </a:extLst>
         </p:spPr>
@@ -5801,7 +5437,7 @@
           </a:prstGeom>
           <a:extLst>
             <a:ext uri="{C572A759-6A51-4108-AA02-DFA0A04FC94B}">
-              <ma14:wrappingTextBoxFlag xmlns:ma14="http://schemas.microsoft.com/office/mac/drawingml/2011/main" xmlns="" val="0"/>
+              <ma14:wrappingTextBoxFlag xmlns="" xmlns:ma14="http://schemas.microsoft.com/office/mac/drawingml/2011/main" val="0"/>
             </a:ext>
           </a:extLst>
         </p:spPr>
@@ -7532,7 +7168,7 @@
           </a:prstGeom>
           <a:extLst>
             <a:ext uri="{C572A759-6A51-4108-AA02-DFA0A04FC94B}">
-              <ma14:wrappingTextBoxFlag xmlns:ma14="http://schemas.microsoft.com/office/mac/drawingml/2011/main" xmlns="" val="0"/>
+              <ma14:wrappingTextBoxFlag xmlns="" xmlns:ma14="http://schemas.microsoft.com/office/mac/drawingml/2011/main" val="0"/>
             </a:ext>
           </a:extLst>
         </p:spPr>
@@ -8057,7 +7693,7 @@
           </a:prstGeom>
           <a:extLst>
             <a:ext uri="{C572A759-6A51-4108-AA02-DFA0A04FC94B}">
-              <ma14:wrappingTextBoxFlag xmlns:ma14="http://schemas.microsoft.com/office/mac/drawingml/2011/main" xmlns="" val="0"/>
+              <ma14:wrappingTextBoxFlag xmlns="" xmlns:ma14="http://schemas.microsoft.com/office/mac/drawingml/2011/main" val="0"/>
             </a:ext>
           </a:extLst>
         </p:spPr>
@@ -10487,7 +10123,7 @@
           </a:prstGeom>
           <a:extLst>
             <a:ext uri="{C572A759-6A51-4108-AA02-DFA0A04FC94B}">
-              <ma14:wrappingTextBoxFlag xmlns:ma14="http://schemas.microsoft.com/office/mac/drawingml/2011/main" xmlns="" val="0"/>
+              <ma14:wrappingTextBoxFlag xmlns="" xmlns:ma14="http://schemas.microsoft.com/office/mac/drawingml/2011/main" val="0"/>
             </a:ext>
           </a:extLst>
         </p:spPr>
@@ -11063,7 +10699,7 @@
           </a:prstGeom>
           <a:extLst>
             <a:ext uri="{C572A759-6A51-4108-AA02-DFA0A04FC94B}">
-              <ma14:wrappingTextBoxFlag xmlns:ma14="http://schemas.microsoft.com/office/mac/drawingml/2011/main" xmlns="" val="0"/>
+              <ma14:wrappingTextBoxFlag xmlns="" xmlns:ma14="http://schemas.microsoft.com/office/mac/drawingml/2011/main" val="0"/>
             </a:ext>
           </a:extLst>
         </p:spPr>
@@ -11391,7 +11027,7 @@
           </a:prstGeom>
           <a:extLst>
             <a:ext uri="{C572A759-6A51-4108-AA02-DFA0A04FC94B}">
-              <ma14:wrappingTextBoxFlag xmlns:ma14="http://schemas.microsoft.com/office/mac/drawingml/2011/main" xmlns="" val="0"/>
+              <ma14:wrappingTextBoxFlag xmlns="" xmlns:ma14="http://schemas.microsoft.com/office/mac/drawingml/2011/main" val="0"/>
             </a:ext>
           </a:extLst>
         </p:spPr>
@@ -11751,7 +11387,7 @@
           </a:prstGeom>
           <a:extLst>
             <a:ext uri="{C572A759-6A51-4108-AA02-DFA0A04FC94B}">
-              <ma14:wrappingTextBoxFlag xmlns="" xmlns:ma14="http://schemas.microsoft.com/office/mac/drawingml/2011/main" val="0"/>
+              <ma14:wrappingTextBoxFlag xmlns:ma14="http://schemas.microsoft.com/office/mac/drawingml/2011/main" xmlns="" val="0"/>
             </a:ext>
           </a:extLst>
         </p:spPr>
@@ -13184,7 +12820,7 @@
           </a:prstGeom>
           <a:extLst>
             <a:ext uri="{C572A759-6A51-4108-AA02-DFA0A04FC94B}">
-              <ma14:wrappingTextBoxFlag xmlns:ma14="http://schemas.microsoft.com/office/mac/drawingml/2011/main" xmlns="" val="0"/>
+              <ma14:wrappingTextBoxFlag xmlns="" xmlns:ma14="http://schemas.microsoft.com/office/mac/drawingml/2011/main" val="0"/>
             </a:ext>
           </a:extLst>
         </p:spPr>
@@ -13280,7 +12916,7 @@
           </a:xfrm>
           <a:extLst>
             <a:ext uri="{C572A759-6A51-4108-AA02-DFA0A04FC94B}">
-              <ma14:wrappingTextBoxFlag xmlns:ma14="http://schemas.microsoft.com/office/mac/drawingml/2011/main" xmlns="" val="0"/>
+              <ma14:wrappingTextBoxFlag xmlns="" xmlns:ma14="http://schemas.microsoft.com/office/mac/drawingml/2011/main" val="0"/>
             </a:ext>
           </a:extLst>
         </p:spPr>
@@ -16479,7 +16115,7 @@
           </a:prstGeom>
           <a:extLst>
             <a:ext uri="{C572A759-6A51-4108-AA02-DFA0A04FC94B}">
-              <ma14:wrappingTextBoxFlag xmlns:ma14="http://schemas.microsoft.com/office/mac/drawingml/2011/main" xmlns="" val="0"/>
+              <ma14:wrappingTextBoxFlag xmlns="" xmlns:ma14="http://schemas.microsoft.com/office/mac/drawingml/2011/main" val="0"/>
             </a:ext>
           </a:extLst>
         </p:spPr>
@@ -16981,7 +16617,7 @@
           </a:prstGeom>
           <a:extLst>
             <a:ext uri="{C572A759-6A51-4108-AA02-DFA0A04FC94B}">
-              <ma14:wrappingTextBoxFlag xmlns:ma14="http://schemas.microsoft.com/office/mac/drawingml/2011/main" xmlns="" val="0"/>
+              <ma14:wrappingTextBoxFlag xmlns="" xmlns:ma14="http://schemas.microsoft.com/office/mac/drawingml/2011/main" val="0"/>
             </a:ext>
           </a:extLst>
         </p:spPr>
@@ -17548,7 +17184,7 @@
           </a:prstGeom>
           <a:extLst>
             <a:ext uri="{C572A759-6A51-4108-AA02-DFA0A04FC94B}">
-              <ma14:wrappingTextBoxFlag xmlns:ma14="http://schemas.microsoft.com/office/mac/drawingml/2011/main" xmlns="" val="0"/>
+              <ma14:wrappingTextBoxFlag xmlns="" xmlns:ma14="http://schemas.microsoft.com/office/mac/drawingml/2011/main" val="0"/>
             </a:ext>
           </a:extLst>
         </p:spPr>
@@ -18429,7 +18065,7 @@
           </a:prstGeom>
           <a:extLst>
             <a:ext uri="{C572A759-6A51-4108-AA02-DFA0A04FC94B}">
-              <ma14:wrappingTextBoxFlag xmlns:ma14="http://schemas.microsoft.com/office/mac/drawingml/2011/main" xmlns="" val="0"/>
+              <ma14:wrappingTextBoxFlag xmlns="" xmlns:ma14="http://schemas.microsoft.com/office/mac/drawingml/2011/main" val="0"/>
             </a:ext>
           </a:extLst>
         </p:spPr>
@@ -21177,7 +20813,7 @@
           </a:prstGeom>
           <a:extLst>
             <a:ext uri="{C572A759-6A51-4108-AA02-DFA0A04FC94B}">
-              <ma14:wrappingTextBoxFlag xmlns:ma14="http://schemas.microsoft.com/office/mac/drawingml/2011/main" xmlns="" val="0"/>
+              <ma14:wrappingTextBoxFlag xmlns="" xmlns:ma14="http://schemas.microsoft.com/office/mac/drawingml/2011/main" val="0"/>
             </a:ext>
           </a:extLst>
         </p:spPr>
@@ -21798,7 +21434,7 @@
           </a:prstGeom>
           <a:extLst>
             <a:ext uri="{C572A759-6A51-4108-AA02-DFA0A04FC94B}">
-              <ma14:wrappingTextBoxFlag xmlns:ma14="http://schemas.microsoft.com/office/mac/drawingml/2011/main" xmlns="" val="0"/>
+              <ma14:wrappingTextBoxFlag xmlns="" xmlns:ma14="http://schemas.microsoft.com/office/mac/drawingml/2011/main" val="0"/>
             </a:ext>
           </a:extLst>
         </p:spPr>
@@ -22701,7 +22337,7 @@
           </a:prstGeom>
           <a:extLst>
             <a:ext uri="{C572A759-6A51-4108-AA02-DFA0A04FC94B}">
-              <ma14:wrappingTextBoxFlag xmlns:ma14="http://schemas.microsoft.com/office/mac/drawingml/2011/main" xmlns="" val="0"/>
+              <ma14:wrappingTextBoxFlag xmlns="" xmlns:ma14="http://schemas.microsoft.com/office/mac/drawingml/2011/main" val="0"/>
             </a:ext>
           </a:extLst>
         </p:spPr>

</xml_diff>